<commit_message>
docs: update presentation deck NexFactory-AI-ppt.pptx
</commit_message>
<xml_diff>
--- a/NexFactory-AI-ppt.pptx
+++ b/NexFactory-AI-ppt.pptx
@@ -1903,15 +1903,24 @@
               <a:buNone/>
             </a:pPr>
             <a:r>
-              <a:rPr lang="en-US" sz="7600" b="1" dirty="0">
+              <a:rPr lang="en-US" sz="7600" b="1" dirty="0" err="1">
                 <a:solidFill>
                   <a:srgbClr val="FFFFFF"/>
                 </a:solidFill>
                 <a:latin typeface="Cambria" pitchFamily="34" charset="0"/>
                 <a:ea typeface="Cambria" pitchFamily="34" charset="-122"/>
-                <a:cs typeface="Cambria" pitchFamily="34" charset="-120"/>
-              </a:rPr>
-              <a:t>PredictIQ</a:t>
+              </a:rPr>
+              <a:t>NexFactory</a:t>
+            </a:r>
+            <a:r>
+              <a:rPr lang="en-US" sz="7600" b="1" dirty="0">
+                <a:solidFill>
+                  <a:srgbClr val="FFFFFF"/>
+                </a:solidFill>
+                <a:latin typeface="Cambria" pitchFamily="34" charset="0"/>
+                <a:ea typeface="Cambria" pitchFamily="34" charset="-122"/>
+              </a:rPr>
+              <a:t> AI</a:t>
             </a:r>
             <a:endParaRPr lang="en-US" sz="7600" dirty="0"/>
           </a:p>
@@ -3555,21 +3564,14 @@
           <a:bodyPr wrap="square" rtlCol="0" anchor="ctr"/>
           <a:lstStyle/>
           <a:p>
-            <a:pPr marL="0" indent="0">
-              <a:buNone/>
-            </a:pPr>
-            <a:r>
-              <a:rPr lang="en-US" sz="900" dirty="0">
+            <a:r>
+              <a:rPr lang="en-US" sz="1000" dirty="0">
                 <a:solidFill>
                   <a:srgbClr val="00D9A3"/>
                 </a:solidFill>
-                <a:latin typeface="Calibri" pitchFamily="34" charset="0"/>
-                <a:ea typeface="Calibri" pitchFamily="34" charset="-122"/>
-                <a:cs typeface="Calibri" pitchFamily="34" charset="-120"/>
-              </a:rPr>
-              <a:t>github.com/team-gamma/predictiq  [update before submission]</a:t>
-            </a:r>
-            <a:endParaRPr lang="en-US" sz="900" dirty="0"/>
+              </a:rPr>
+              <a:t>https://github.com/Priyanshi0907/NexFactory</a:t>
+            </a:r>
           </a:p>
         </p:txBody>
       </p:sp>
@@ -3699,21 +3701,27 @@
           <a:bodyPr wrap="square" rtlCol="0" anchor="ctr"/>
           <a:lstStyle/>
           <a:p>
-            <a:pPr marL="0" indent="0">
-              <a:buNone/>
-            </a:pPr>
-            <a:r>
-              <a:rPr lang="en-US" sz="900" dirty="0">
+            <a:r>
+              <a:rPr lang="en-US" sz="1000" dirty="0">
                 <a:solidFill>
                   <a:srgbClr val="00D9A3"/>
                 </a:solidFill>
-                <a:latin typeface="Calibri" pitchFamily="34" charset="0"/>
-                <a:ea typeface="Calibri" pitchFamily="34" charset="-122"/>
-                <a:cs typeface="Calibri" pitchFamily="34" charset="-120"/>
-              </a:rPr>
-              <a:t>predictiq.vercel.app  [update before submission]</a:t>
-            </a:r>
-            <a:endParaRPr lang="en-US" sz="900" dirty="0"/>
+              </a:rPr>
+              <a:t>https://nex-factory.vercel</a:t>
+            </a:r>
+            <a:r>
+              <a:rPr lang="en-US" sz="1000">
+                <a:solidFill>
+                  <a:srgbClr val="00D9A3"/>
+                </a:solidFill>
+              </a:rPr>
+              <a:t>.app</a:t>
+            </a:r>
+            <a:endParaRPr lang="en-US" sz="1000" dirty="0">
+              <a:solidFill>
+                <a:srgbClr val="00D9A3"/>
+              </a:solidFill>
+            </a:endParaRPr>
           </a:p>
         </p:txBody>
       </p:sp>

</xml_diff>